<commit_message>
docs: record Chinook evaluation results
</commit_message>
<xml_diff>
--- a/docs/reference/task8-analysis.pptx
+++ b/docs/reference/task8-analysis.pptx
@@ -5,7 +5,7 @@
     <p:sldMasterId id="2147483648" r:id="rId1"/>
   </p:sldMasterIdLst>
   <p:notesMasterIdLst>
-    <p:notesMasterId r:id="rId20"/>
+    <p:notesMasterId r:id="rId17"/>
   </p:notesMasterIdLst>
   <p:sldIdLst>
     <p:sldId id="256" r:id="rId3"/>
@@ -22,9 +22,9 @@
     <p:sldId id="2885" r:id="rId14"/>
     <p:sldId id="2888" r:id="rId15"/>
     <p:sldId id="2889" r:id="rId16"/>
-    <p:sldId id="2886" r:id="rId17"/>
-    <p:sldId id="2887" r:id="rId18"/>
-    <p:sldId id="1364" r:id="rId19"/>
+    <p:sldId id="2886" r:id="rId18"/>
+    <p:sldId id="2887" r:id="rId19"/>
+    <p:sldId id="1364" r:id="rId20"/>
   </p:sldIdLst>
   <p:sldSz cx="12192000" cy="6858000"/>
   <p:notesSz cx="6858000" cy="9144000"/>
@@ -534,6 +534,54 @@
 </file>
 
 <file path=ppt/notesSlides/notesSlide1.xml><?xml version="1.0" encoding="utf-8"?>
+<p:notes xmlns:a="http://schemas.openxmlformats.org/drawingml/2006/main" xmlns:r="http://schemas.openxmlformats.org/officeDocument/2006/relationships" xmlns:p="http://schemas.openxmlformats.org/presentationml/2006/main">
+  <p:cSld>
+    <p:spTree>
+      <p:nvGrpSpPr>
+        <p:cNvPr id="1" name=""/>
+        <p:cNvGrpSpPr/>
+        <p:nvPr/>
+      </p:nvGrpSpPr>
+      <p:grpSpPr/>
+      <p:sp>
+        <p:nvSpPr>
+          <p:cNvPr id="2" name="幻灯片图像占位符 1"/>
+          <p:cNvSpPr>
+            <a:spLocks noGrp="1"/>
+          </p:cNvSpPr>
+          <p:nvPr>
+            <p:ph type="sldImg" idx="2"/>
+          </p:nvPr>
+        </p:nvSpPr>
+        <p:spPr/>
+      </p:sp>
+      <p:sp>
+        <p:nvSpPr>
+          <p:cNvPr id="3" name="文本占位符 2"/>
+          <p:cNvSpPr>
+            <a:spLocks noGrp="1"/>
+          </p:cNvSpPr>
+          <p:nvPr>
+            <p:ph type="body" idx="3"/>
+          </p:nvPr>
+        </p:nvSpPr>
+        <p:spPr/>
+        <p:txBody>
+          <a:bodyPr/>
+          <a:p>
+            <a:endParaRPr lang="zh-CN" altLang="en-US"/>
+          </a:p>
+        </p:txBody>
+      </p:sp>
+    </p:spTree>
+  </p:cSld>
+  <p:clrMapOvr>
+    <a:masterClrMapping/>
+  </p:clrMapOvr>
+</p:notes>
+</file>
+
+<file path=ppt/notesSlides/notesSlide2.xml><?xml version="1.0" encoding="utf-8"?>
 <p:notes xmlns:a="http://schemas.openxmlformats.org/drawingml/2006/main" xmlns:r="http://schemas.openxmlformats.org/officeDocument/2006/relationships" xmlns:p="http://schemas.openxmlformats.org/presentationml/2006/main">
   <p:cSld>
     <p:spTree>
@@ -33499,11 +33547,13 @@
           <a:bodyPr/>
           <a:p>
             <a:r>
-              <a:t>选择与</a:t>
-            </a:r>
-            <a:r>
-              <a:t>分工</a:t>
-            </a:r>
+              <a:t>选择与分工</a:t>
+            </a:r>
+            <a:r>
+              <a:rPr lang="en-US" altLang="zh-CN"/>
+              <a:t> pua</a:t>
+            </a:r>
+            <a:endParaRPr lang="en-US" altLang="zh-CN"/>
           </a:p>
         </p:txBody>
       </p:sp>
@@ -34647,8 +34697,16 @@
                         <a:rPr lang="zh-CN" altLang="en-US" sz="1200"/>
                       </a:br>
                       <a:r>
+                        <a:rPr lang="zh-CN" altLang="en-US" sz="1200">
+                          <a:highlight>
+                            <a:srgbClr val="FFFF00"/>
+                          </a:highlight>
+                        </a:rPr>
+                        <a:t>优先跨源问答</a:t>
+                      </a:r>
+                      <a:r>
                         <a:rPr lang="zh-CN" altLang="en-US" sz="1200"/>
-                        <a:t>优先跨源问答（</a:t>
+                        <a:t>（</a:t>
                       </a:r>
                       <a:r>
                         <a:rPr lang="en-US" altLang="zh-CN" sz="1200"/>
@@ -35176,7 +35234,23 @@
                             <a:srgbClr val="FFFF00"/>
                           </a:highlight>
                         </a:rPr>
-                        <a:t>优先跨源问答</a:t>
+                        <a:t>优先</a:t>
+                      </a:r>
+                      <a:r>
+                        <a:rPr lang="en-US" altLang="zh-CN" sz="1200" b="1">
+                          <a:highlight>
+                            <a:srgbClr val="FFFF00"/>
+                          </a:highlight>
+                        </a:rPr>
+                        <a:t>:</a:t>
+                      </a:r>
+                      <a:r>
+                        <a:rPr lang="zh-CN" altLang="en-US" sz="1200" b="1">
+                          <a:highlight>
+                            <a:srgbClr val="FFFF00"/>
+                          </a:highlight>
+                        </a:rPr>
+                        <a:t>跨源问答</a:t>
                       </a:r>
                       <a:r>
                         <a:rPr lang="zh-CN" altLang="en-US" sz="1200">

</xml_diff>